<commit_message>
updating class_6 ppt and agenda
</commit_message>
<xml_diff>
--- a/docs/lectures/in-class_activities/class_6.pptx
+++ b/docs/lectures/in-class_activities/class_6.pptx
@@ -13,8 +13,8 @@
     <p:sldId id="716" r:id="rId4"/>
     <p:sldId id="714" r:id="rId5"/>
     <p:sldId id="712" r:id="rId6"/>
-    <p:sldId id="717" r:id="rId7"/>
-    <p:sldId id="718" r:id="rId8"/>
+    <p:sldId id="720" r:id="rId7"/>
+    <p:sldId id="721" r:id="rId8"/>
     <p:sldId id="719" r:id="rId9"/>
   </p:sldIdLst>
   <p:sldSz cx="12192000" cy="6858000"/>
@@ -204,7 +204,7 @@
           <a:p>
             <a:fld id="{6AC7DB66-C6D6-B24E-B345-FA3772C924EA}" type="datetimeFigureOut">
               <a:rPr lang="en-US" smtClean="0"/>
-              <a:t>10/12/20</a:t>
+              <a:t>10/10/25</a:t>
             </a:fld>
             <a:endParaRPr lang="en-US"/>
           </a:p>
@@ -515,16 +515,7 @@
           <a:bodyPr/>
           <a:lstStyle/>
           <a:p>
-            <a:r>
-              <a:rPr lang="en-US"/>
-              <a:t>Name one microparasite</a:t>
-            </a:r>
-          </a:p>
-          <a:p>
-            <a:r>
-              <a:rPr lang="en-US"/>
-              <a:t>https://www.polleverywhere.com/free_text_polls/3idB10Bf7nevIFLEnX1SM</a:t>
-            </a:r>
+            <a:endParaRPr lang="en-US"/>
           </a:p>
         </p:txBody>
       </p:sp>
@@ -545,7 +536,7 @@
           <a:p>
             <a:fld id="{4218707C-A528-5347-B512-111D9A72273A}" type="slidenum">
               <a:rPr lang="en-US" smtClean="0"/>
-              <a:t>6</a:t>
+              <a:t>1</a:t>
             </a:fld>
             <a:endParaRPr lang="en-US"/>
           </a:p>
@@ -554,7 +545,7 @@
     </p:spTree>
     <p:extLst>
       <p:ext uri="{BB962C8B-B14F-4D97-AF65-F5344CB8AC3E}">
-        <p14:creationId xmlns:p14="http://schemas.microsoft.com/office/powerpoint/2010/main" val="273040532"/>
+        <p14:creationId xmlns:p14="http://schemas.microsoft.com/office/powerpoint/2010/main" val="2576742374"/>
       </p:ext>
     </p:extLst>
   </p:cSld>
@@ -608,15 +599,448 @@
           <a:bodyPr/>
           <a:lstStyle/>
           <a:p>
+            <a:endParaRPr lang="en-US"/>
+          </a:p>
+        </p:txBody>
+      </p:sp>
+      <p:sp>
+        <p:nvSpPr>
+          <p:cNvPr id="4" name="Slide Number Placeholder 3"/>
+          <p:cNvSpPr>
+            <a:spLocks noGrp="1"/>
+          </p:cNvSpPr>
+          <p:nvPr>
+            <p:ph type="sldNum" sz="quarter" idx="5"/>
+          </p:nvPr>
+        </p:nvSpPr>
+        <p:spPr/>
+        <p:txBody>
+          <a:bodyPr/>
+          <a:lstStyle/>
+          <a:p>
+            <a:fld id="{4218707C-A528-5347-B512-111D9A72273A}" type="slidenum">
+              <a:rPr lang="en-US" smtClean="0"/>
+              <a:t>2</a:t>
+            </a:fld>
+            <a:endParaRPr lang="en-US"/>
+          </a:p>
+        </p:txBody>
+      </p:sp>
+    </p:spTree>
+    <p:extLst>
+      <p:ext uri="{BB962C8B-B14F-4D97-AF65-F5344CB8AC3E}">
+        <p14:creationId xmlns:p14="http://schemas.microsoft.com/office/powerpoint/2010/main" val="1136688175"/>
+      </p:ext>
+    </p:extLst>
+  </p:cSld>
+  <p:clrMapOvr>
+    <a:masterClrMapping/>
+  </p:clrMapOvr>
+</p:notes>
+</file>
+
+<file path=ppt/notesSlides/notesSlide3.xml><?xml version="1.0" encoding="utf-8"?>
+<p:notes xmlns:a="http://schemas.openxmlformats.org/drawingml/2006/main" xmlns:r="http://schemas.openxmlformats.org/officeDocument/2006/relationships" xmlns:p="http://schemas.openxmlformats.org/presentationml/2006/main">
+  <p:cSld>
+    <p:spTree>
+      <p:nvGrpSpPr>
+        <p:cNvPr id="1" name=""/>
+        <p:cNvGrpSpPr/>
+        <p:nvPr/>
+      </p:nvGrpSpPr>
+      <p:grpSpPr>
+        <a:xfrm>
+          <a:off x="0" y="0"/>
+          <a:ext cx="0" cy="0"/>
+          <a:chOff x="0" y="0"/>
+          <a:chExt cx="0" cy="0"/>
+        </a:xfrm>
+      </p:grpSpPr>
+      <p:sp>
+        <p:nvSpPr>
+          <p:cNvPr id="2" name="Slide Image Placeholder 1"/>
+          <p:cNvSpPr>
+            <a:spLocks noGrp="1" noRot="1" noChangeAspect="1"/>
+          </p:cNvSpPr>
+          <p:nvPr>
+            <p:ph type="sldImg"/>
+          </p:nvPr>
+        </p:nvSpPr>
+        <p:spPr/>
+      </p:sp>
+      <p:sp>
+        <p:nvSpPr>
+          <p:cNvPr id="3" name="Notes Placeholder 2"/>
+          <p:cNvSpPr>
+            <a:spLocks noGrp="1"/>
+          </p:cNvSpPr>
+          <p:nvPr>
+            <p:ph type="body" idx="1"/>
+          </p:nvPr>
+        </p:nvSpPr>
+        <p:spPr/>
+        <p:txBody>
+          <a:bodyPr/>
+          <a:lstStyle/>
+          <a:p>
+            <a:endParaRPr lang="en-US"/>
+          </a:p>
+        </p:txBody>
+      </p:sp>
+      <p:sp>
+        <p:nvSpPr>
+          <p:cNvPr id="4" name="Slide Number Placeholder 3"/>
+          <p:cNvSpPr>
+            <a:spLocks noGrp="1"/>
+          </p:cNvSpPr>
+          <p:nvPr>
+            <p:ph type="sldNum" sz="quarter" idx="5"/>
+          </p:nvPr>
+        </p:nvSpPr>
+        <p:spPr/>
+        <p:txBody>
+          <a:bodyPr/>
+          <a:lstStyle/>
+          <a:p>
+            <a:fld id="{4218707C-A528-5347-B512-111D9A72273A}" type="slidenum">
+              <a:rPr lang="en-US" smtClean="0"/>
+              <a:t>3</a:t>
+            </a:fld>
+            <a:endParaRPr lang="en-US"/>
+          </a:p>
+        </p:txBody>
+      </p:sp>
+    </p:spTree>
+    <p:extLst>
+      <p:ext uri="{BB962C8B-B14F-4D97-AF65-F5344CB8AC3E}">
+        <p14:creationId xmlns:p14="http://schemas.microsoft.com/office/powerpoint/2010/main" val="604756555"/>
+      </p:ext>
+    </p:extLst>
+  </p:cSld>
+  <p:clrMapOvr>
+    <a:masterClrMapping/>
+  </p:clrMapOvr>
+</p:notes>
+</file>
+
+<file path=ppt/notesSlides/notesSlide4.xml><?xml version="1.0" encoding="utf-8"?>
+<p:notes xmlns:a="http://schemas.openxmlformats.org/drawingml/2006/main" xmlns:r="http://schemas.openxmlformats.org/officeDocument/2006/relationships" xmlns:p="http://schemas.openxmlformats.org/presentationml/2006/main">
+  <p:cSld>
+    <p:spTree>
+      <p:nvGrpSpPr>
+        <p:cNvPr id="1" name=""/>
+        <p:cNvGrpSpPr/>
+        <p:nvPr/>
+      </p:nvGrpSpPr>
+      <p:grpSpPr>
+        <a:xfrm>
+          <a:off x="0" y="0"/>
+          <a:ext cx="0" cy="0"/>
+          <a:chOff x="0" y="0"/>
+          <a:chExt cx="0" cy="0"/>
+        </a:xfrm>
+      </p:grpSpPr>
+      <p:sp>
+        <p:nvSpPr>
+          <p:cNvPr id="2" name="Slide Image Placeholder 1"/>
+          <p:cNvSpPr>
+            <a:spLocks noGrp="1" noRot="1" noChangeAspect="1"/>
+          </p:cNvSpPr>
+          <p:nvPr>
+            <p:ph type="sldImg"/>
+          </p:nvPr>
+        </p:nvSpPr>
+        <p:spPr/>
+      </p:sp>
+      <p:sp>
+        <p:nvSpPr>
+          <p:cNvPr id="3" name="Notes Placeholder 2"/>
+          <p:cNvSpPr>
+            <a:spLocks noGrp="1"/>
+          </p:cNvSpPr>
+          <p:nvPr>
+            <p:ph type="body" idx="1"/>
+          </p:nvPr>
+        </p:nvSpPr>
+        <p:spPr/>
+        <p:txBody>
+          <a:bodyPr/>
+          <a:lstStyle/>
+          <a:p>
+            <a:endParaRPr lang="en-US"/>
+          </a:p>
+        </p:txBody>
+      </p:sp>
+      <p:sp>
+        <p:nvSpPr>
+          <p:cNvPr id="4" name="Slide Number Placeholder 3"/>
+          <p:cNvSpPr>
+            <a:spLocks noGrp="1"/>
+          </p:cNvSpPr>
+          <p:nvPr>
+            <p:ph type="sldNum" sz="quarter" idx="5"/>
+          </p:nvPr>
+        </p:nvSpPr>
+        <p:spPr/>
+        <p:txBody>
+          <a:bodyPr/>
+          <a:lstStyle/>
+          <a:p>
+            <a:fld id="{4218707C-A528-5347-B512-111D9A72273A}" type="slidenum">
+              <a:rPr lang="en-US" smtClean="0"/>
+              <a:t>4</a:t>
+            </a:fld>
+            <a:endParaRPr lang="en-US"/>
+          </a:p>
+        </p:txBody>
+      </p:sp>
+    </p:spTree>
+    <p:extLst>
+      <p:ext uri="{BB962C8B-B14F-4D97-AF65-F5344CB8AC3E}">
+        <p14:creationId xmlns:p14="http://schemas.microsoft.com/office/powerpoint/2010/main" val="3867715331"/>
+      </p:ext>
+    </p:extLst>
+  </p:cSld>
+  <p:clrMapOvr>
+    <a:masterClrMapping/>
+  </p:clrMapOvr>
+</p:notes>
+</file>
+
+<file path=ppt/notesSlides/notesSlide5.xml><?xml version="1.0" encoding="utf-8"?>
+<p:notes xmlns:a="http://schemas.openxmlformats.org/drawingml/2006/main" xmlns:r="http://schemas.openxmlformats.org/officeDocument/2006/relationships" xmlns:p="http://schemas.openxmlformats.org/presentationml/2006/main">
+  <p:cSld>
+    <p:spTree>
+      <p:nvGrpSpPr>
+        <p:cNvPr id="1" name=""/>
+        <p:cNvGrpSpPr/>
+        <p:nvPr/>
+      </p:nvGrpSpPr>
+      <p:grpSpPr>
+        <a:xfrm>
+          <a:off x="0" y="0"/>
+          <a:ext cx="0" cy="0"/>
+          <a:chOff x="0" y="0"/>
+          <a:chExt cx="0" cy="0"/>
+        </a:xfrm>
+      </p:grpSpPr>
+      <p:sp>
+        <p:nvSpPr>
+          <p:cNvPr id="2" name="Slide Image Placeholder 1"/>
+          <p:cNvSpPr>
+            <a:spLocks noGrp="1" noRot="1" noChangeAspect="1"/>
+          </p:cNvSpPr>
+          <p:nvPr>
+            <p:ph type="sldImg"/>
+          </p:nvPr>
+        </p:nvSpPr>
+        <p:spPr/>
+      </p:sp>
+      <p:sp>
+        <p:nvSpPr>
+          <p:cNvPr id="3" name="Notes Placeholder 2"/>
+          <p:cNvSpPr>
+            <a:spLocks noGrp="1"/>
+          </p:cNvSpPr>
+          <p:nvPr>
+            <p:ph type="body" idx="1"/>
+          </p:nvPr>
+        </p:nvSpPr>
+        <p:spPr/>
+        <p:txBody>
+          <a:bodyPr/>
+          <a:lstStyle/>
+          <a:p>
+            <a:endParaRPr lang="en-US"/>
+          </a:p>
+        </p:txBody>
+      </p:sp>
+      <p:sp>
+        <p:nvSpPr>
+          <p:cNvPr id="4" name="Slide Number Placeholder 3"/>
+          <p:cNvSpPr>
+            <a:spLocks noGrp="1"/>
+          </p:cNvSpPr>
+          <p:nvPr>
+            <p:ph type="sldNum" sz="quarter" idx="5"/>
+          </p:nvPr>
+        </p:nvSpPr>
+        <p:spPr/>
+        <p:txBody>
+          <a:bodyPr/>
+          <a:lstStyle/>
+          <a:p>
+            <a:fld id="{4218707C-A528-5347-B512-111D9A72273A}" type="slidenum">
+              <a:rPr lang="en-US" smtClean="0"/>
+              <a:t>5</a:t>
+            </a:fld>
+            <a:endParaRPr lang="en-US"/>
+          </a:p>
+        </p:txBody>
+      </p:sp>
+    </p:spTree>
+    <p:extLst>
+      <p:ext uri="{BB962C8B-B14F-4D97-AF65-F5344CB8AC3E}">
+        <p14:creationId xmlns:p14="http://schemas.microsoft.com/office/powerpoint/2010/main" val="2062307480"/>
+      </p:ext>
+    </p:extLst>
+  </p:cSld>
+  <p:clrMapOvr>
+    <a:masterClrMapping/>
+  </p:clrMapOvr>
+</p:notes>
+</file>
+
+<file path=ppt/notesSlides/notesSlide6.xml><?xml version="1.0" encoding="utf-8"?>
+<p:notes xmlns:a="http://schemas.openxmlformats.org/drawingml/2006/main" xmlns:r="http://schemas.openxmlformats.org/officeDocument/2006/relationships" xmlns:p="http://schemas.openxmlformats.org/presentationml/2006/main">
+  <p:cSld>
+    <p:spTree>
+      <p:nvGrpSpPr>
+        <p:cNvPr id="1" name=""/>
+        <p:cNvGrpSpPr/>
+        <p:nvPr/>
+      </p:nvGrpSpPr>
+      <p:grpSpPr>
+        <a:xfrm>
+          <a:off x="0" y="0"/>
+          <a:ext cx="0" cy="0"/>
+          <a:chOff x="0" y="0"/>
+          <a:chExt cx="0" cy="0"/>
+        </a:xfrm>
+      </p:grpSpPr>
+      <p:sp>
+        <p:nvSpPr>
+          <p:cNvPr id="2" name="Slide Image Placeholder 1"/>
+          <p:cNvSpPr>
+            <a:spLocks noGrp="1" noRot="1" noChangeAspect="1"/>
+          </p:cNvSpPr>
+          <p:nvPr>
+            <p:ph type="sldImg"/>
+          </p:nvPr>
+        </p:nvSpPr>
+        <p:spPr/>
+      </p:sp>
+      <p:sp>
+        <p:nvSpPr>
+          <p:cNvPr id="3" name="Notes Placeholder 2"/>
+          <p:cNvSpPr>
+            <a:spLocks noGrp="1"/>
+          </p:cNvSpPr>
+          <p:nvPr>
+            <p:ph type="body" idx="1"/>
+          </p:nvPr>
+        </p:nvSpPr>
+        <p:spPr/>
+        <p:txBody>
+          <a:bodyPr/>
+          <a:lstStyle/>
+          <a:p>
             <a:r>
               <a:rPr lang="en-US"/>
-              <a:t>Name one macroparasite</a:t>
+              <a:t>Do not modify the notes in this section to avoid tampering with the Poll Everywhere activity.
+More info at polleverywhere.com/support
+Name one microparasite</a:t>
             </a:r>
           </a:p>
           <a:p>
             <a:r>
               <a:rPr lang="en-US"/>
-              <a:t>https://www.polleverywhere.com/free_text_polls/zodaukr6NLGvdAJSporaL</a:t>
+              <a:t>https://www.polleverywhere.com/free_text_polls/1tmJyt0UcEOmnwFFsYh1n</a:t>
+            </a:r>
+          </a:p>
+        </p:txBody>
+      </p:sp>
+      <p:sp>
+        <p:nvSpPr>
+          <p:cNvPr id="4" name="Slide Number Placeholder 3"/>
+          <p:cNvSpPr>
+            <a:spLocks noGrp="1"/>
+          </p:cNvSpPr>
+          <p:nvPr>
+            <p:ph type="sldNum" sz="quarter" idx="5"/>
+          </p:nvPr>
+        </p:nvSpPr>
+        <p:spPr/>
+        <p:txBody>
+          <a:bodyPr/>
+          <a:lstStyle/>
+          <a:p>
+            <a:fld id="{4218707C-A528-5347-B512-111D9A72273A}" type="slidenum">
+              <a:rPr lang="en-US" smtClean="0"/>
+              <a:t>6</a:t>
+            </a:fld>
+            <a:endParaRPr lang="en-US"/>
+          </a:p>
+        </p:txBody>
+      </p:sp>
+    </p:spTree>
+    <p:extLst>
+      <p:ext uri="{BB962C8B-B14F-4D97-AF65-F5344CB8AC3E}">
+        <p14:creationId xmlns:p14="http://schemas.microsoft.com/office/powerpoint/2010/main" val="1309610201"/>
+      </p:ext>
+    </p:extLst>
+  </p:cSld>
+  <p:clrMapOvr>
+    <a:masterClrMapping/>
+  </p:clrMapOvr>
+</p:notes>
+</file>
+
+<file path=ppt/notesSlides/notesSlide7.xml><?xml version="1.0" encoding="utf-8"?>
+<p:notes xmlns:a="http://schemas.openxmlformats.org/drawingml/2006/main" xmlns:r="http://schemas.openxmlformats.org/officeDocument/2006/relationships" xmlns:p="http://schemas.openxmlformats.org/presentationml/2006/main">
+  <p:cSld>
+    <p:spTree>
+      <p:nvGrpSpPr>
+        <p:cNvPr id="1" name=""/>
+        <p:cNvGrpSpPr/>
+        <p:nvPr/>
+      </p:nvGrpSpPr>
+      <p:grpSpPr>
+        <a:xfrm>
+          <a:off x="0" y="0"/>
+          <a:ext cx="0" cy="0"/>
+          <a:chOff x="0" y="0"/>
+          <a:chExt cx="0" cy="0"/>
+        </a:xfrm>
+      </p:grpSpPr>
+      <p:sp>
+        <p:nvSpPr>
+          <p:cNvPr id="2" name="Slide Image Placeholder 1"/>
+          <p:cNvSpPr>
+            <a:spLocks noGrp="1" noRot="1" noChangeAspect="1"/>
+          </p:cNvSpPr>
+          <p:nvPr>
+            <p:ph type="sldImg"/>
+          </p:nvPr>
+        </p:nvSpPr>
+        <p:spPr/>
+      </p:sp>
+      <p:sp>
+        <p:nvSpPr>
+          <p:cNvPr id="3" name="Notes Placeholder 2"/>
+          <p:cNvSpPr>
+            <a:spLocks noGrp="1"/>
+          </p:cNvSpPr>
+          <p:nvPr>
+            <p:ph type="body" idx="1"/>
+          </p:nvPr>
+        </p:nvSpPr>
+        <p:spPr/>
+        <p:txBody>
+          <a:bodyPr/>
+          <a:lstStyle/>
+          <a:p>
+            <a:r>
+              <a:rPr lang="en-US"/>
+              <a:t>Do not modify the notes in this section to avoid tampering with the Poll Everywhere activity.
+More info at polleverywhere.com/support
+Name one macroparasite</a:t>
+            </a:r>
+          </a:p>
+          <a:p>
+            <a:r>
+              <a:rPr lang="en-US"/>
+              <a:t>https://www.polleverywhere.com/free_text_polls/FzcFp94mZGXZ0OD73sF5S</a:t>
             </a:r>
           </a:p>
         </p:txBody>
@@ -647,7 +1071,91 @@
     </p:spTree>
     <p:extLst>
       <p:ext uri="{BB962C8B-B14F-4D97-AF65-F5344CB8AC3E}">
-        <p14:creationId xmlns:p14="http://schemas.microsoft.com/office/powerpoint/2010/main" val="4139511666"/>
+        <p14:creationId xmlns:p14="http://schemas.microsoft.com/office/powerpoint/2010/main" val="2995886872"/>
+      </p:ext>
+    </p:extLst>
+  </p:cSld>
+  <p:clrMapOvr>
+    <a:masterClrMapping/>
+  </p:clrMapOvr>
+</p:notes>
+</file>
+
+<file path=ppt/notesSlides/notesSlide8.xml><?xml version="1.0" encoding="utf-8"?>
+<p:notes xmlns:a="http://schemas.openxmlformats.org/drawingml/2006/main" xmlns:r="http://schemas.openxmlformats.org/officeDocument/2006/relationships" xmlns:p="http://schemas.openxmlformats.org/presentationml/2006/main">
+  <p:cSld>
+    <p:spTree>
+      <p:nvGrpSpPr>
+        <p:cNvPr id="1" name=""/>
+        <p:cNvGrpSpPr/>
+        <p:nvPr/>
+      </p:nvGrpSpPr>
+      <p:grpSpPr>
+        <a:xfrm>
+          <a:off x="0" y="0"/>
+          <a:ext cx="0" cy="0"/>
+          <a:chOff x="0" y="0"/>
+          <a:chExt cx="0" cy="0"/>
+        </a:xfrm>
+      </p:grpSpPr>
+      <p:sp>
+        <p:nvSpPr>
+          <p:cNvPr id="2" name="Slide Image Placeholder 1"/>
+          <p:cNvSpPr>
+            <a:spLocks noGrp="1" noRot="1" noChangeAspect="1"/>
+          </p:cNvSpPr>
+          <p:nvPr>
+            <p:ph type="sldImg"/>
+          </p:nvPr>
+        </p:nvSpPr>
+        <p:spPr/>
+      </p:sp>
+      <p:sp>
+        <p:nvSpPr>
+          <p:cNvPr id="3" name="Notes Placeholder 2"/>
+          <p:cNvSpPr>
+            <a:spLocks noGrp="1"/>
+          </p:cNvSpPr>
+          <p:nvPr>
+            <p:ph type="body" idx="1"/>
+          </p:nvPr>
+        </p:nvSpPr>
+        <p:spPr/>
+        <p:txBody>
+          <a:bodyPr/>
+          <a:lstStyle/>
+          <a:p>
+            <a:endParaRPr lang="en-US"/>
+          </a:p>
+        </p:txBody>
+      </p:sp>
+      <p:sp>
+        <p:nvSpPr>
+          <p:cNvPr id="4" name="Slide Number Placeholder 3"/>
+          <p:cNvSpPr>
+            <a:spLocks noGrp="1"/>
+          </p:cNvSpPr>
+          <p:nvPr>
+            <p:ph type="sldNum" sz="quarter" idx="5"/>
+          </p:nvPr>
+        </p:nvSpPr>
+        <p:spPr/>
+        <p:txBody>
+          <a:bodyPr/>
+          <a:lstStyle/>
+          <a:p>
+            <a:fld id="{4218707C-A528-5347-B512-111D9A72273A}" type="slidenum">
+              <a:rPr lang="en-US" smtClean="0"/>
+              <a:t>8</a:t>
+            </a:fld>
+            <a:endParaRPr lang="en-US"/>
+          </a:p>
+        </p:txBody>
+      </p:sp>
+    </p:spTree>
+    <p:extLst>
+      <p:ext uri="{BB962C8B-B14F-4D97-AF65-F5344CB8AC3E}">
+        <p14:creationId xmlns:p14="http://schemas.microsoft.com/office/powerpoint/2010/main" val="1279833344"/>
       </p:ext>
     </p:extLst>
   </p:cSld>
@@ -804,7 +1312,7 @@
           <a:p>
             <a:fld id="{21DDE3A9-9D48-7D40-AF95-520AE186EA5D}" type="datetimeFigureOut">
               <a:rPr lang="en-US" smtClean="0"/>
-              <a:t>10/12/20</a:t>
+              <a:t>10/10/25</a:t>
             </a:fld>
             <a:endParaRPr lang="en-US"/>
           </a:p>
@@ -1002,7 +1510,7 @@
           <a:p>
             <a:fld id="{21DDE3A9-9D48-7D40-AF95-520AE186EA5D}" type="datetimeFigureOut">
               <a:rPr lang="en-US" smtClean="0"/>
-              <a:t>10/12/20</a:t>
+              <a:t>10/10/25</a:t>
             </a:fld>
             <a:endParaRPr lang="en-US"/>
           </a:p>
@@ -1210,7 +1718,7 @@
           <a:p>
             <a:fld id="{21DDE3A9-9D48-7D40-AF95-520AE186EA5D}" type="datetimeFigureOut">
               <a:rPr lang="en-US" smtClean="0"/>
-              <a:t>10/12/20</a:t>
+              <a:t>10/10/25</a:t>
             </a:fld>
             <a:endParaRPr lang="en-US"/>
           </a:p>
@@ -1408,7 +1916,7 @@
           <a:p>
             <a:fld id="{21DDE3A9-9D48-7D40-AF95-520AE186EA5D}" type="datetimeFigureOut">
               <a:rPr lang="en-US" smtClean="0"/>
-              <a:t>10/12/20</a:t>
+              <a:t>10/10/25</a:t>
             </a:fld>
             <a:endParaRPr lang="en-US"/>
           </a:p>
@@ -1683,7 +2191,7 @@
           <a:p>
             <a:fld id="{21DDE3A9-9D48-7D40-AF95-520AE186EA5D}" type="datetimeFigureOut">
               <a:rPr lang="en-US" smtClean="0"/>
-              <a:t>10/12/20</a:t>
+              <a:t>10/10/25</a:t>
             </a:fld>
             <a:endParaRPr lang="en-US"/>
           </a:p>
@@ -1948,7 +2456,7 @@
           <a:p>
             <a:fld id="{21DDE3A9-9D48-7D40-AF95-520AE186EA5D}" type="datetimeFigureOut">
               <a:rPr lang="en-US" smtClean="0"/>
-              <a:t>10/12/20</a:t>
+              <a:t>10/10/25</a:t>
             </a:fld>
             <a:endParaRPr lang="en-US"/>
           </a:p>
@@ -2360,7 +2868,7 @@
           <a:p>
             <a:fld id="{21DDE3A9-9D48-7D40-AF95-520AE186EA5D}" type="datetimeFigureOut">
               <a:rPr lang="en-US" smtClean="0"/>
-              <a:t>10/12/20</a:t>
+              <a:t>10/10/25</a:t>
             </a:fld>
             <a:endParaRPr lang="en-US"/>
           </a:p>
@@ -2501,7 +3009,7 @@
           <a:p>
             <a:fld id="{21DDE3A9-9D48-7D40-AF95-520AE186EA5D}" type="datetimeFigureOut">
               <a:rPr lang="en-US" smtClean="0"/>
-              <a:t>10/12/20</a:t>
+              <a:t>10/10/25</a:t>
             </a:fld>
             <a:endParaRPr lang="en-US"/>
           </a:p>
@@ -2614,7 +3122,7 @@
           <a:p>
             <a:fld id="{21DDE3A9-9D48-7D40-AF95-520AE186EA5D}" type="datetimeFigureOut">
               <a:rPr lang="en-US" smtClean="0"/>
-              <a:t>10/12/20</a:t>
+              <a:t>10/10/25</a:t>
             </a:fld>
             <a:endParaRPr lang="en-US"/>
           </a:p>
@@ -2925,7 +3433,7 @@
           <a:p>
             <a:fld id="{21DDE3A9-9D48-7D40-AF95-520AE186EA5D}" type="datetimeFigureOut">
               <a:rPr lang="en-US" smtClean="0"/>
-              <a:t>10/12/20</a:t>
+              <a:t>10/10/25</a:t>
             </a:fld>
             <a:endParaRPr lang="en-US"/>
           </a:p>
@@ -3213,7 +3721,7 @@
           <a:p>
             <a:fld id="{21DDE3A9-9D48-7D40-AF95-520AE186EA5D}" type="datetimeFigureOut">
               <a:rPr lang="en-US" smtClean="0"/>
-              <a:t>10/12/20</a:t>
+              <a:t>10/10/25</a:t>
             </a:fld>
             <a:endParaRPr lang="en-US"/>
           </a:p>
@@ -3454,7 +3962,7 @@
           <a:p>
             <a:fld id="{21DDE3A9-9D48-7D40-AF95-520AE186EA5D}" type="datetimeFigureOut">
               <a:rPr lang="en-US" smtClean="0"/>
-              <a:t>10/12/20</a:t>
+              <a:t>10/10/25</a:t>
             </a:fld>
             <a:endParaRPr lang="en-US"/>
           </a:p>
@@ -3921,9 +4429,9 @@
                   </a:schemeClr>
                 </a:solidFill>
                 <a:latin typeface="Avenir Book" panose="02000503020000020003" pitchFamily="2" charset="0"/>
-                <a:cs typeface="Avenir Roman"/>
+                <a:cs typeface="Avenir"/>
               </a:rPr>
-              <a:t>Practical session 6</a:t>
+              <a:t>Class 6</a:t>
             </a:r>
             <a:r>
               <a:rPr lang="en-US" sz="4800" dirty="0">
@@ -3933,7 +4441,7 @@
                   </a:schemeClr>
                 </a:solidFill>
                 <a:latin typeface="Avenir Book" panose="02000503020000020003" pitchFamily="2" charset="0"/>
-                <a:cs typeface="Avenir Roman"/>
+                <a:cs typeface="Avenir"/>
               </a:rPr>
               <a:t>: </a:t>
             </a:r>
@@ -3943,7 +4451,7 @@
                   <a:srgbClr val="FFFFFF"/>
                 </a:solidFill>
                 <a:latin typeface="Avenir Book" panose="02000503020000020003" pitchFamily="2" charset="0"/>
-                <a:cs typeface="Avenir Roman"/>
+                <a:cs typeface="Avenir"/>
               </a:rPr>
               <a:t>Turbellarians, </a:t>
             </a:r>
@@ -3953,7 +4461,7 @@
                   <a:srgbClr val="FFFFFF"/>
                 </a:solidFill>
                 <a:latin typeface="Avenir Book" panose="02000503020000020003" pitchFamily="2" charset="0"/>
-                <a:cs typeface="Avenir Roman"/>
+                <a:cs typeface="Avenir"/>
               </a:rPr>
               <a:t>fecampiids</a:t>
             </a:r>
@@ -3963,7 +4471,7 @@
                   <a:srgbClr val="FFFFFF"/>
                 </a:solidFill>
                 <a:latin typeface="Avenir Book" panose="02000503020000020003" pitchFamily="2" charset="0"/>
-                <a:cs typeface="Avenir Roman"/>
+                <a:cs typeface="Avenir"/>
               </a:rPr>
               <a:t>, and </a:t>
             </a:r>
@@ -3973,7 +4481,7 @@
                   <a:srgbClr val="FFFFFF"/>
                 </a:solidFill>
                 <a:latin typeface="Avenir Book" panose="02000503020000020003" pitchFamily="2" charset="0"/>
-                <a:cs typeface="Avenir Roman"/>
+                <a:cs typeface="Avenir"/>
               </a:rPr>
               <a:t>monogenes</a:t>
             </a:r>
@@ -3982,7 +4490,7 @@
                 <a:srgbClr val="FFFFFF"/>
               </a:solidFill>
               <a:latin typeface="Avenir Book" panose="02000503020000020003" pitchFamily="2" charset="0"/>
-              <a:cs typeface="Avenir Roman"/>
+              <a:cs typeface="Avenir"/>
             </a:endParaRPr>
           </a:p>
         </p:txBody>
@@ -4059,8 +4567,8 @@
             </a:pPr>
             <a:r>
               <a:rPr lang="en-US" sz="3500" b="1" dirty="0">
-                <a:latin typeface="Avenir Roman"/>
-                <a:cs typeface="Avenir Roman"/>
+                <a:latin typeface="Avenir"/>
+                <a:cs typeface="Avenir"/>
               </a:rPr>
               <a:t>Q1. commensal versus parasite</a:t>
             </a:r>
@@ -4109,8 +4617,8 @@
             </a:pPr>
             <a:r>
               <a:rPr lang="en-US" sz="3000" b="1" dirty="0">
-                <a:latin typeface="Avenir Roman"/>
-                <a:cs typeface="Avenir Roman"/>
+                <a:latin typeface="Avenir"/>
+                <a:cs typeface="Avenir"/>
               </a:rPr>
               <a:t>Ponder on your own (5 m) then share with the class (5 m).</a:t>
             </a:r>
@@ -4132,11 +4640,11 @@
           <p:nvPr/>
         </p:nvPicPr>
         <p:blipFill>
-          <a:blip r:embed="rId2">
+          <a:blip r:embed="rId3">
             <a:extLst>
               <a:ext uri="{BEBA8EAE-BF5A-486C-A8C5-ECC9F3942E4B}">
                 <a14:imgProps xmlns:a14="http://schemas.microsoft.com/office/drawing/2010/main">
-                  <a14:imgLayer r:embed="rId3">
+                  <a14:imgLayer r:embed="rId4">
                     <a14:imgEffect>
                       <a14:backgroundRemoval t="9867" b="89867" l="6196" r="91630">
                         <a14:foregroundMark x1="39022" y1="64000" x2="39022" y2="64000"/>
@@ -4228,7 +4736,7 @@
           <p:nvPr/>
         </p:nvPicPr>
         <p:blipFill>
-          <a:blip r:embed="rId4">
+          <a:blip r:embed="rId5">
             <a:extLst>
               <a:ext uri="{28A0092B-C50C-407E-A947-70E740481C1C}">
                 <a14:useLocalDpi xmlns:a14="http://schemas.microsoft.com/office/drawing/2010/main" val="0"/>
@@ -4315,8 +4823,8 @@
             </a:pPr>
             <a:r>
               <a:rPr lang="en-US" sz="2400" dirty="0">
-                <a:latin typeface="Avenir Roman"/>
-                <a:cs typeface="Avenir Roman"/>
+                <a:latin typeface="Avenir"/>
+                <a:cs typeface="Avenir"/>
               </a:rPr>
               <a:t>Turbellarians are generally considered to be commensals, but the line between commensal and parasite can sometimes get blurry.</a:t>
             </a:r>
@@ -4329,22 +4837,22 @@
             </a:pPr>
             <a:r>
               <a:rPr lang="en-US" sz="2400" dirty="0">
-                <a:latin typeface="Avenir Roman"/>
-                <a:cs typeface="Avenir Roman"/>
+                <a:latin typeface="Avenir"/>
+                <a:cs typeface="Avenir"/>
               </a:rPr>
               <a:t>Think about the </a:t>
             </a:r>
             <a:r>
               <a:rPr lang="en-US" sz="2400" dirty="0" err="1">
-                <a:latin typeface="Avenir Roman"/>
-                <a:cs typeface="Avenir Roman"/>
+                <a:latin typeface="Avenir"/>
+                <a:cs typeface="Avenir"/>
               </a:rPr>
               <a:t>temnocephalids</a:t>
             </a:r>
             <a:r>
               <a:rPr lang="en-US" sz="2400" dirty="0">
-                <a:latin typeface="Avenir Roman"/>
-                <a:cs typeface="Avenir Roman"/>
+                <a:latin typeface="Avenir"/>
+                <a:cs typeface="Avenir"/>
               </a:rPr>
               <a:t> (turbellarians parasitic on freshwater crustaceans like crayfish).</a:t>
             </a:r>
@@ -4357,22 +4865,22 @@
             </a:pPr>
             <a:r>
               <a:rPr lang="en-US" sz="2400" dirty="0">
-                <a:latin typeface="Avenir Roman"/>
-                <a:cs typeface="Avenir Roman"/>
+                <a:latin typeface="Avenir"/>
+                <a:cs typeface="Avenir"/>
               </a:rPr>
               <a:t>What are some circumstances in which </a:t>
             </a:r>
             <a:r>
               <a:rPr lang="en-US" sz="2400" dirty="0" err="1">
-                <a:latin typeface="Avenir Roman"/>
-                <a:cs typeface="Avenir Roman"/>
+                <a:latin typeface="Avenir"/>
+                <a:cs typeface="Avenir"/>
               </a:rPr>
               <a:t>temnocephalid</a:t>
             </a:r>
             <a:r>
               <a:rPr lang="en-US" sz="2400" dirty="0">
-                <a:latin typeface="Avenir Roman"/>
-                <a:cs typeface="Avenir Roman"/>
+                <a:latin typeface="Avenir"/>
+                <a:cs typeface="Avenir"/>
               </a:rPr>
               <a:t> commensals might become parasitic?</a:t>
             </a:r>
@@ -4385,8 +4893,8 @@
             </a:pPr>
             <a:r>
               <a:rPr lang="en-US" sz="2400" dirty="0">
-                <a:latin typeface="Avenir Roman"/>
-                <a:cs typeface="Avenir Roman"/>
+                <a:latin typeface="Avenir"/>
+                <a:cs typeface="Avenir"/>
               </a:rPr>
               <a:t>Generate at least three ideas.</a:t>
             </a:r>
@@ -4694,8 +5202,8 @@
             </a:pPr>
             <a:r>
               <a:rPr lang="en-US" sz="3500" b="1" dirty="0">
-                <a:latin typeface="Avenir Roman"/>
-                <a:cs typeface="Avenir Roman"/>
+                <a:latin typeface="Avenir"/>
+                <a:cs typeface="Avenir"/>
               </a:rPr>
               <a:t>Q2. killing your host</a:t>
             </a:r>
@@ -4744,8 +5252,8 @@
             </a:pPr>
             <a:r>
               <a:rPr lang="en-US" sz="3000" b="1" dirty="0">
-                <a:latin typeface="Avenir Roman"/>
-                <a:cs typeface="Avenir Roman"/>
+                <a:latin typeface="Avenir"/>
+                <a:cs typeface="Avenir"/>
               </a:rPr>
               <a:t>Ponder on your own (5 m), discuss with a partner (5 m), then share with the class (5 m).</a:t>
             </a:r>
@@ -4767,11 +5275,11 @@
           <p:nvPr/>
         </p:nvPicPr>
         <p:blipFill>
-          <a:blip r:embed="rId2">
+          <a:blip r:embed="rId3">
             <a:extLst>
               <a:ext uri="{BEBA8EAE-BF5A-486C-A8C5-ECC9F3942E4B}">
                 <a14:imgProps xmlns:a14="http://schemas.microsoft.com/office/drawing/2010/main">
-                  <a14:imgLayer r:embed="rId3">
+                  <a14:imgLayer r:embed="rId4">
                     <a14:imgEffect>
                       <a14:backgroundRemoval t="9867" b="89867" l="6196" r="91630">
                         <a14:foregroundMark x1="39022" y1="64000" x2="39022" y2="64000"/>
@@ -4890,8 +5398,8 @@
             </a:pPr>
             <a:r>
               <a:rPr lang="en-US" sz="2400" dirty="0">
-                <a:latin typeface="Avenir Roman"/>
-                <a:cs typeface="Avenir Roman"/>
+                <a:latin typeface="Avenir"/>
+                <a:cs typeface="Avenir"/>
               </a:rPr>
               <a:t>Generally parasites don’t have incentives to kill their hosts. </a:t>
             </a:r>
@@ -4902,22 +5410,22 @@
             </a:pPr>
             <a:r>
               <a:rPr lang="en-US" sz="2400" dirty="0">
-                <a:latin typeface="Avenir Roman"/>
-                <a:cs typeface="Avenir Roman"/>
+                <a:latin typeface="Avenir"/>
+                <a:cs typeface="Avenir"/>
               </a:rPr>
               <a:t>So why do the </a:t>
             </a:r>
             <a:r>
               <a:rPr lang="en-US" sz="2400" dirty="0" err="1">
-                <a:latin typeface="Avenir Roman"/>
-                <a:cs typeface="Avenir Roman"/>
+                <a:latin typeface="Avenir"/>
+                <a:cs typeface="Avenir"/>
               </a:rPr>
               <a:t>fecampiids</a:t>
             </a:r>
             <a:r>
               <a:rPr lang="en-US" sz="2400" dirty="0">
-                <a:latin typeface="Avenir Roman"/>
-                <a:cs typeface="Avenir Roman"/>
+                <a:latin typeface="Avenir"/>
+                <a:cs typeface="Avenir"/>
               </a:rPr>
               <a:t> do it?</a:t>
             </a:r>
@@ -4939,7 +5447,7 @@
           <p:nvPr/>
         </p:nvPicPr>
         <p:blipFill rotWithShape="1">
-          <a:blip r:embed="rId4">
+          <a:blip r:embed="rId5">
             <a:extLst>
               <a:ext uri="{28A0092B-C50C-407E-A947-70E740481C1C}">
                 <a14:useLocalDpi xmlns:a14="http://schemas.microsoft.com/office/drawing/2010/main" val="0"/>
@@ -5179,8 +5687,8 @@
             </a:pPr>
             <a:r>
               <a:rPr lang="en-US" sz="3500" b="1" dirty="0">
-                <a:latin typeface="Avenir Roman"/>
-                <a:cs typeface="Avenir Roman"/>
+                <a:latin typeface="Avenir"/>
+                <a:cs typeface="Avenir"/>
               </a:rPr>
               <a:t>Q3. host specificity</a:t>
             </a:r>
@@ -5229,8 +5737,8 @@
             </a:pPr>
             <a:r>
               <a:rPr lang="en-US" sz="3000" b="1" dirty="0">
-                <a:latin typeface="Avenir Roman"/>
-                <a:cs typeface="Avenir Roman"/>
+                <a:latin typeface="Avenir"/>
+                <a:cs typeface="Avenir"/>
               </a:rPr>
               <a:t>Google Doc on your own (5 m), then discuss and make a debate plan with your group       (5 m), then debate with the class (5 m).</a:t>
             </a:r>
@@ -5252,11 +5760,11 @@
           <p:nvPr/>
         </p:nvPicPr>
         <p:blipFill>
-          <a:blip r:embed="rId2">
+          <a:blip r:embed="rId3">
             <a:extLst>
               <a:ext uri="{BEBA8EAE-BF5A-486C-A8C5-ECC9F3942E4B}">
                 <a14:imgProps xmlns:a14="http://schemas.microsoft.com/office/drawing/2010/main">
-                  <a14:imgLayer r:embed="rId3">
+                  <a14:imgLayer r:embed="rId4">
                     <a14:imgEffect>
                       <a14:backgroundRemoval t="9867" b="89867" l="6196" r="91630">
                         <a14:foregroundMark x1="39022" y1="64000" x2="39022" y2="64000"/>
@@ -5369,22 +5877,22 @@
             </a:pPr>
             <a:r>
               <a:rPr lang="en-US" sz="2400" dirty="0">
-                <a:latin typeface="Avenir Roman"/>
-                <a:cs typeface="Avenir Roman"/>
+                <a:latin typeface="Avenir"/>
+                <a:cs typeface="Avenir"/>
               </a:rPr>
               <a:t>The </a:t>
             </a:r>
             <a:r>
               <a:rPr lang="en-US" sz="2400" dirty="0" err="1">
-                <a:latin typeface="Avenir Roman"/>
-                <a:cs typeface="Avenir Roman"/>
+                <a:latin typeface="Avenir"/>
+                <a:cs typeface="Avenir"/>
               </a:rPr>
               <a:t>monogenes</a:t>
             </a:r>
             <a:r>
               <a:rPr lang="en-US" sz="2400" dirty="0">
-                <a:latin typeface="Avenir Roman"/>
-                <a:cs typeface="Avenir Roman"/>
+                <a:latin typeface="Avenir"/>
+                <a:cs typeface="Avenir"/>
               </a:rPr>
               <a:t> exhibit extreme host specificity. If you are a species looking to increase your fitness, is it good or bad to evolve extreme host specificity?</a:t>
             </a:r>
@@ -5397,8 +5905,8 @@
             </a:pPr>
             <a:r>
               <a:rPr lang="en-US" sz="2400" dirty="0">
-                <a:latin typeface="Avenir Roman"/>
-                <a:cs typeface="Avenir Roman"/>
+                <a:latin typeface="Avenir"/>
+                <a:cs typeface="Avenir"/>
               </a:rPr>
               <a:t>First, brainstorm ideas on our Google Doc.</a:t>
             </a:r>
@@ -5411,8 +5919,8 @@
             </a:pPr>
             <a:r>
               <a:rPr lang="en-US" sz="2400" dirty="0">
-                <a:latin typeface="Avenir Roman"/>
-                <a:cs typeface="Avenir Roman"/>
+                <a:latin typeface="Avenir"/>
+                <a:cs typeface="Avenir"/>
               </a:rPr>
               <a:t>Then, the class will be split into six groups.</a:t>
             </a:r>
@@ -5425,8 +5933,8 @@
             </a:pPr>
             <a:r>
               <a:rPr lang="en-US" sz="2400" dirty="0">
-                <a:latin typeface="Avenir Roman"/>
-                <a:cs typeface="Avenir Roman"/>
+                <a:latin typeface="Avenir"/>
+                <a:cs typeface="Avenir"/>
               </a:rPr>
               <a:t>Three groups will argue for the benefits of extreme host specificity.</a:t>
             </a:r>
@@ -5439,8 +5947,8 @@
             </a:pPr>
             <a:r>
               <a:rPr lang="en-US" sz="2400" dirty="0">
-                <a:latin typeface="Avenir Roman"/>
-                <a:cs typeface="Avenir Roman"/>
+                <a:latin typeface="Avenir"/>
+                <a:cs typeface="Avenir"/>
               </a:rPr>
               <a:t>Three groups will argue for the risks of extreme host specificity. </a:t>
             </a:r>
@@ -5462,7 +5970,7 @@
           <p:nvPr/>
         </p:nvPicPr>
         <p:blipFill rotWithShape="1">
-          <a:blip r:embed="rId4">
+          <a:blip r:embed="rId5">
             <a:extLst>
               <a:ext uri="{28A0092B-C50C-407E-A947-70E740481C1C}">
                 <a14:useLocalDpi xmlns:a14="http://schemas.microsoft.com/office/drawing/2010/main" val="0"/>
@@ -5849,22 +6357,22 @@
             </a:pPr>
             <a:r>
               <a:rPr lang="en-US" sz="4000" b="1" dirty="0">
-                <a:latin typeface="Avenir Roman"/>
-                <a:cs typeface="Avenir Roman"/>
+                <a:latin typeface="Avenir"/>
+                <a:cs typeface="Avenir"/>
               </a:rPr>
               <a:t>Q4. </a:t>
             </a:r>
             <a:r>
               <a:rPr lang="en-US" sz="4000" b="1" dirty="0" err="1">
-                <a:latin typeface="Avenir Roman"/>
-                <a:cs typeface="Avenir Roman"/>
+                <a:latin typeface="Avenir"/>
+                <a:cs typeface="Avenir"/>
               </a:rPr>
               <a:t>macroparasites</a:t>
             </a:r>
             <a:r>
               <a:rPr lang="en-US" sz="4000" b="1" dirty="0">
-                <a:latin typeface="Avenir Roman"/>
-                <a:cs typeface="Avenir Roman"/>
+                <a:latin typeface="Avenir"/>
+                <a:cs typeface="Avenir"/>
               </a:rPr>
               <a:t> versus microparasites</a:t>
             </a:r>
@@ -5886,7 +6394,7 @@
           <p:nvPr/>
         </p:nvPicPr>
         <p:blipFill>
-          <a:blip r:embed="rId2"/>
+          <a:blip r:embed="rId3"/>
           <a:stretch>
             <a:fillRect/>
           </a:stretch>
@@ -5936,7 +6444,7 @@
           <p:cNvPr id="2" name="Title 1">
             <a:extLst>
               <a:ext uri="{FF2B5EF4-FFF2-40B4-BE49-F238E27FC236}">
-                <a16:creationId xmlns:a16="http://schemas.microsoft.com/office/drawing/2014/main" id="{3A7F8AD8-6CFF-964A-9698-D845FCE62C4F}"/>
+                <a16:creationId xmlns:a16="http://schemas.microsoft.com/office/drawing/2014/main" id="{02DB1818-9C93-6725-04C0-97E7EBE41C99}"/>
               </a:ext>
             </a:extLst>
           </p:cNvPr>
@@ -5961,7 +6469,7 @@
           <p:cNvPr id="3" name="Subtitle 2">
             <a:extLst>
               <a:ext uri="{FF2B5EF4-FFF2-40B4-BE49-F238E27FC236}">
-                <a16:creationId xmlns:a16="http://schemas.microsoft.com/office/drawing/2014/main" id="{A106BAC6-FC6D-C947-9C02-DCC5CF6764D4}"/>
+                <a16:creationId xmlns:a16="http://schemas.microsoft.com/office/drawing/2014/main" id="{6C63245C-DD27-66E5-A94E-10E3386295FC}"/>
               </a:ext>
             </a:extLst>
           </p:cNvPr>
@@ -5983,10 +6491,10 @@
       </p:sp>
       <p:pic>
         <p:nvPicPr>
-          <p:cNvPr id="5" name="slide.url=https://www.polleverywhere.com/free_text_polls/3idB10Bf7nevIFLEnX1SM">
-            <a:extLst>
-              <a:ext uri="{FF2B5EF4-FFF2-40B4-BE49-F238E27FC236}">
-                <a16:creationId xmlns:a16="http://schemas.microsoft.com/office/drawing/2014/main" id="{B2863E43-DD50-1D47-B799-BBB02C3EE0C8}"/>
+          <p:cNvPr id="5" name="slide.url=https://www.polleverywhere.com/free_text_polls/1tmJyt0UcEOmnwFFsYh1n">
+            <a:extLst>
+              <a:ext uri="{FF2B5EF4-FFF2-40B4-BE49-F238E27FC236}">
+                <a16:creationId xmlns:a16="http://schemas.microsoft.com/office/drawing/2014/main" id="{17088A43-A610-8331-129F-D82B05363400}"/>
               </a:ext>
             </a:extLst>
           </p:cNvPr>
@@ -6014,7 +6522,7 @@
     </p:spTree>
     <p:extLst>
       <p:ext uri="{BB962C8B-B14F-4D97-AF65-F5344CB8AC3E}">
-        <p14:creationId xmlns:p14="http://schemas.microsoft.com/office/powerpoint/2010/main" val="1830948849"/>
+        <p14:creationId xmlns:p14="http://schemas.microsoft.com/office/powerpoint/2010/main" val="1331798325"/>
       </p:ext>
     </p:extLst>
   </p:cSld>
@@ -6046,7 +6554,7 @@
           <p:cNvPr id="2" name="Title 1">
             <a:extLst>
               <a:ext uri="{FF2B5EF4-FFF2-40B4-BE49-F238E27FC236}">
-                <a16:creationId xmlns:a16="http://schemas.microsoft.com/office/drawing/2014/main" id="{348F90B9-451D-1943-88EB-BE493EF3083D}"/>
+                <a16:creationId xmlns:a16="http://schemas.microsoft.com/office/drawing/2014/main" id="{5D35C8B7-B36C-3B54-9BFA-DEEA48D638FA}"/>
               </a:ext>
             </a:extLst>
           </p:cNvPr>
@@ -6071,7 +6579,7 @@
           <p:cNvPr id="3" name="Subtitle 2">
             <a:extLst>
               <a:ext uri="{FF2B5EF4-FFF2-40B4-BE49-F238E27FC236}">
-                <a16:creationId xmlns:a16="http://schemas.microsoft.com/office/drawing/2014/main" id="{FD06435E-BB3A-924D-B20A-5B5AE1D6A786}"/>
+                <a16:creationId xmlns:a16="http://schemas.microsoft.com/office/drawing/2014/main" id="{89AF5A37-6138-4221-9B26-26511483CD86}"/>
               </a:ext>
             </a:extLst>
           </p:cNvPr>
@@ -6093,10 +6601,10 @@
       </p:sp>
       <p:pic>
         <p:nvPicPr>
-          <p:cNvPr id="5" name="slide.url=https://www.polleverywhere.com/free_text_polls/zodaukr6NLGvdAJSporaL">
-            <a:extLst>
-              <a:ext uri="{FF2B5EF4-FFF2-40B4-BE49-F238E27FC236}">
-                <a16:creationId xmlns:a16="http://schemas.microsoft.com/office/drawing/2014/main" id="{323CFA25-E4C7-B046-B24C-5F371C5A0F53}"/>
+          <p:cNvPr id="5" name="slide.url=https://www.polleverywhere.com/free_text_polls/FzcFp94mZGXZ0OD73sF5S">
+            <a:extLst>
+              <a:ext uri="{FF2B5EF4-FFF2-40B4-BE49-F238E27FC236}">
+                <a16:creationId xmlns:a16="http://schemas.microsoft.com/office/drawing/2014/main" id="{9046046F-2FA1-F6D4-DA80-EE76CA1AB4E0}"/>
               </a:ext>
             </a:extLst>
           </p:cNvPr>
@@ -6124,7 +6632,7 @@
     </p:spTree>
     <p:extLst>
       <p:ext uri="{BB962C8B-B14F-4D97-AF65-F5344CB8AC3E}">
-        <p14:creationId xmlns:p14="http://schemas.microsoft.com/office/powerpoint/2010/main" val="883445388"/>
+        <p14:creationId xmlns:p14="http://schemas.microsoft.com/office/powerpoint/2010/main" val="3511999113"/>
       </p:ext>
     </p:extLst>
   </p:cSld>
@@ -6201,9 +6709,9 @@
                   </a:schemeClr>
                 </a:solidFill>
                 <a:latin typeface="Avenir Book" panose="02000503020000020003" pitchFamily="2" charset="0"/>
-                <a:cs typeface="Avenir Roman"/>
+                <a:cs typeface="Avenir"/>
               </a:rPr>
-              <a:t>Practical session 6</a:t>
+              <a:t>Class 6</a:t>
             </a:r>
             <a:r>
               <a:rPr lang="en-US" sz="4800" dirty="0">
@@ -6213,7 +6721,7 @@
                   </a:schemeClr>
                 </a:solidFill>
                 <a:latin typeface="Avenir Book" panose="02000503020000020003" pitchFamily="2" charset="0"/>
-                <a:cs typeface="Avenir Roman"/>
+                <a:cs typeface="Avenir"/>
               </a:rPr>
               <a:t>: </a:t>
             </a:r>
@@ -6223,7 +6731,7 @@
                   <a:srgbClr val="FFFFFF"/>
                 </a:solidFill>
                 <a:latin typeface="Avenir Book" panose="02000503020000020003" pitchFamily="2" charset="0"/>
-                <a:cs typeface="Avenir Roman"/>
+                <a:cs typeface="Avenir"/>
               </a:rPr>
               <a:t>Turbellarians, </a:t>
             </a:r>
@@ -6233,7 +6741,7 @@
                   <a:srgbClr val="FFFFFF"/>
                 </a:solidFill>
                 <a:latin typeface="Avenir Book" panose="02000503020000020003" pitchFamily="2" charset="0"/>
-                <a:cs typeface="Avenir Roman"/>
+                <a:cs typeface="Avenir"/>
               </a:rPr>
               <a:t>fecampiids</a:t>
             </a:r>
@@ -6243,7 +6751,7 @@
                   <a:srgbClr val="FFFFFF"/>
                 </a:solidFill>
                 <a:latin typeface="Avenir Book" panose="02000503020000020003" pitchFamily="2" charset="0"/>
-                <a:cs typeface="Avenir Roman"/>
+                <a:cs typeface="Avenir"/>
               </a:rPr>
               <a:t>, and </a:t>
             </a:r>
@@ -6253,7 +6761,7 @@
                   <a:srgbClr val="FFFFFF"/>
                 </a:solidFill>
                 <a:latin typeface="Avenir Book" panose="02000503020000020003" pitchFamily="2" charset="0"/>
-                <a:cs typeface="Avenir Roman"/>
+                <a:cs typeface="Avenir"/>
               </a:rPr>
               <a:t>monogenes</a:t>
             </a:r>
@@ -6262,7 +6770,7 @@
                 <a:srgbClr val="FFFFFF"/>
               </a:solidFill>
               <a:latin typeface="Avenir Book" panose="02000503020000020003" pitchFamily="2" charset="0"/>
-              <a:cs typeface="Avenir Roman"/>
+              <a:cs typeface="Avenir"/>
             </a:endParaRPr>
           </a:p>
         </p:txBody>

</xml_diff>

<commit_message>
getting rid of reference to old control/elim/eradic project in Lab 3
</commit_message>
<xml_diff>
--- a/docs/lectures/in-class_activities/class_6.pptx
+++ b/docs/lectures/in-class_activities/class_6.pptx
@@ -204,7 +204,7 @@
           <a:p>
             <a:fld id="{6AC7DB66-C6D6-B24E-B345-FA3772C924EA}" type="datetimeFigureOut">
               <a:rPr lang="en-US" smtClean="0"/>
-              <a:t>10/10/25</a:t>
+              <a:t>10/13/25</a:t>
             </a:fld>
             <a:endParaRPr lang="en-US"/>
           </a:p>
@@ -1312,7 +1312,7 @@
           <a:p>
             <a:fld id="{21DDE3A9-9D48-7D40-AF95-520AE186EA5D}" type="datetimeFigureOut">
               <a:rPr lang="en-US" smtClean="0"/>
-              <a:t>10/10/25</a:t>
+              <a:t>10/13/25</a:t>
             </a:fld>
             <a:endParaRPr lang="en-US"/>
           </a:p>
@@ -1510,7 +1510,7 @@
           <a:p>
             <a:fld id="{21DDE3A9-9D48-7D40-AF95-520AE186EA5D}" type="datetimeFigureOut">
               <a:rPr lang="en-US" smtClean="0"/>
-              <a:t>10/10/25</a:t>
+              <a:t>10/13/25</a:t>
             </a:fld>
             <a:endParaRPr lang="en-US"/>
           </a:p>
@@ -1718,7 +1718,7 @@
           <a:p>
             <a:fld id="{21DDE3A9-9D48-7D40-AF95-520AE186EA5D}" type="datetimeFigureOut">
               <a:rPr lang="en-US" smtClean="0"/>
-              <a:t>10/10/25</a:t>
+              <a:t>10/13/25</a:t>
             </a:fld>
             <a:endParaRPr lang="en-US"/>
           </a:p>
@@ -1916,7 +1916,7 @@
           <a:p>
             <a:fld id="{21DDE3A9-9D48-7D40-AF95-520AE186EA5D}" type="datetimeFigureOut">
               <a:rPr lang="en-US" smtClean="0"/>
-              <a:t>10/10/25</a:t>
+              <a:t>10/13/25</a:t>
             </a:fld>
             <a:endParaRPr lang="en-US"/>
           </a:p>
@@ -2191,7 +2191,7 @@
           <a:p>
             <a:fld id="{21DDE3A9-9D48-7D40-AF95-520AE186EA5D}" type="datetimeFigureOut">
               <a:rPr lang="en-US" smtClean="0"/>
-              <a:t>10/10/25</a:t>
+              <a:t>10/13/25</a:t>
             </a:fld>
             <a:endParaRPr lang="en-US"/>
           </a:p>
@@ -2456,7 +2456,7 @@
           <a:p>
             <a:fld id="{21DDE3A9-9D48-7D40-AF95-520AE186EA5D}" type="datetimeFigureOut">
               <a:rPr lang="en-US" smtClean="0"/>
-              <a:t>10/10/25</a:t>
+              <a:t>10/13/25</a:t>
             </a:fld>
             <a:endParaRPr lang="en-US"/>
           </a:p>
@@ -2868,7 +2868,7 @@
           <a:p>
             <a:fld id="{21DDE3A9-9D48-7D40-AF95-520AE186EA5D}" type="datetimeFigureOut">
               <a:rPr lang="en-US" smtClean="0"/>
-              <a:t>10/10/25</a:t>
+              <a:t>10/13/25</a:t>
             </a:fld>
             <a:endParaRPr lang="en-US"/>
           </a:p>
@@ -3009,7 +3009,7 @@
           <a:p>
             <a:fld id="{21DDE3A9-9D48-7D40-AF95-520AE186EA5D}" type="datetimeFigureOut">
               <a:rPr lang="en-US" smtClean="0"/>
-              <a:t>10/10/25</a:t>
+              <a:t>10/13/25</a:t>
             </a:fld>
             <a:endParaRPr lang="en-US"/>
           </a:p>
@@ -3122,7 +3122,7 @@
           <a:p>
             <a:fld id="{21DDE3A9-9D48-7D40-AF95-520AE186EA5D}" type="datetimeFigureOut">
               <a:rPr lang="en-US" smtClean="0"/>
-              <a:t>10/10/25</a:t>
+              <a:t>10/13/25</a:t>
             </a:fld>
             <a:endParaRPr lang="en-US"/>
           </a:p>
@@ -3433,7 +3433,7 @@
           <a:p>
             <a:fld id="{21DDE3A9-9D48-7D40-AF95-520AE186EA5D}" type="datetimeFigureOut">
               <a:rPr lang="en-US" smtClean="0"/>
-              <a:t>10/10/25</a:t>
+              <a:t>10/13/25</a:t>
             </a:fld>
             <a:endParaRPr lang="en-US"/>
           </a:p>
@@ -3721,7 +3721,7 @@
           <a:p>
             <a:fld id="{21DDE3A9-9D48-7D40-AF95-520AE186EA5D}" type="datetimeFigureOut">
               <a:rPr lang="en-US" smtClean="0"/>
-              <a:t>10/10/25</a:t>
+              <a:t>10/13/25</a:t>
             </a:fld>
             <a:endParaRPr lang="en-US"/>
           </a:p>
@@ -3962,7 +3962,7 @@
           <a:p>
             <a:fld id="{21DDE3A9-9D48-7D40-AF95-520AE186EA5D}" type="datetimeFigureOut">
               <a:rPr lang="en-US" smtClean="0"/>
-              <a:t>10/10/25</a:t>
+              <a:t>10/13/25</a:t>
             </a:fld>
             <a:endParaRPr lang="en-US"/>
           </a:p>
@@ -5740,7 +5740,21 @@
                 <a:latin typeface="Avenir"/>
                 <a:cs typeface="Avenir"/>
               </a:rPr>
-              <a:t>Google Doc on your own (5 m), then discuss and make a debate plan with your group       (5 m), then debate with the class (5 m).</a:t>
+              <a:t>Google Doc on your own (5 m), then discuss and make a debate plan with your </a:t>
+            </a:r>
+            <a:r>
+              <a:rPr lang="en-US" sz="3000" b="1">
+                <a:latin typeface="Avenir"/>
+                <a:cs typeface="Avenir"/>
+              </a:rPr>
+              <a:t>group        (</a:t>
+            </a:r>
+            <a:r>
+              <a:rPr lang="en-US" sz="3000" b="1" dirty="0">
+                <a:latin typeface="Avenir"/>
+                <a:cs typeface="Avenir"/>
+              </a:rPr>
+              <a:t>5 m), then debate with the class (5 m).</a:t>
             </a:r>
           </a:p>
         </p:txBody>

</xml_diff>